<commit_message>
Add robustness (period-split) table slide to presentation deck
Insert a slide after the headline result showing gross/slippage/net P&L and
contracts for the development, held-out, and full periods: the rule loses in
both in-sample and out-of-sample, with gross roughly flat throughout.

Co-Authored-By: Claude Opus 4.8 (1M context) <noreply@anthropic.com>
</commit_message>
<xml_diff>
--- a/presentation/FINM37000_Corn_Futures.pptx
+++ b/presentation/FINM37000_Corn_Futures.pptx
@@ -13,6 +13,7 @@
     <p:sldId id="258" r:id="rId4"/>
     <p:sldId id="259" r:id="rId5"/>
     <p:sldId id="260" r:id="rId6"/>
+    <p:sldId id="263" r:id="rId14"/>
     <p:sldId id="261" r:id="rId7"/>
     <p:sldId id="262" r:id="rId8"/>
   </p:sldIdLst>
@@ -739,6 +740,31 @@
         </p:nvSpPr>
         <p:spPr/>
       </p:sp>
+    </p:spTree>
+  </p:cSld>
+  <p:clrMapOvr>
+    <a:masterClrMapping/>
+  </p:clrMapOvr>
+</p:notes>
+</file>
+
+<file path=ppt/notesSlides/notesSlide8.xml><?xml version="1.0" encoding="utf-8"?>
+<p:notes xmlns:a="http://schemas.openxmlformats.org/drawingml/2006/main" xmlns:p="http://schemas.openxmlformats.org/presentationml/2006/main" xmlns:r="http://schemas.openxmlformats.org/officeDocument/2006/relationships">
+  <p:cSld>
+    <p:spTree>
+      <p:nvGrpSpPr>
+        <p:cNvPr id="1" name=""/>
+        <p:cNvGrpSpPr/>
+        <p:nvPr/>
+      </p:nvGrpSpPr>
+      <p:grpSpPr>
+        <a:xfrm>
+          <a:off x="0" y="0"/>
+          <a:ext cx="0" cy="0"/>
+          <a:chOff x="0" y="0"/>
+          <a:chExt cx="0" cy="0"/>
+        </a:xfrm>
+      </p:grpSpPr>
     </p:spTree>
   </p:cSld>
   <p:clrMapOvr>
@@ -4782,6 +4808,602 @@
                 </a:solidFill>
               </a:rPr>
               <a:t>–  order-flow features; source an expectations series to finish the USDA study</a:t>
+            </a:r>
+          </a:p>
+        </p:txBody>
+      </p:sp>
+    </p:spTree>
+  </p:cSld>
+  <p:clrMapOvr>
+    <a:masterClrMapping/>
+  </p:clrMapOvr>
+</p:sld>
+</file>
+
+<file path=ppt/slides/slide8.xml><?xml version="1.0" encoding="utf-8"?>
+<p:sld xmlns:a="http://schemas.openxmlformats.org/drawingml/2006/main" xmlns:p="http://schemas.openxmlformats.org/presentationml/2006/main" xmlns:r="http://schemas.openxmlformats.org/officeDocument/2006/relationships">
+  <p:cSld>
+    <p:spTree>
+      <p:nvGrpSpPr>
+        <p:cNvPr id="1" name=""/>
+        <p:cNvGrpSpPr/>
+        <p:nvPr/>
+      </p:nvGrpSpPr>
+      <p:grpSpPr/>
+      <p:sp>
+        <p:nvSpPr>
+          <p:cNvPr id="2" name="TextBox 1"/>
+          <p:cNvSpPr txBox="1"/>
+          <p:nvPr/>
+        </p:nvSpPr>
+        <p:spPr>
+          <a:xfrm>
+            <a:off x="548640" y="320040"/>
+            <a:ext cx="11064240" cy="822960"/>
+          </a:xfrm>
+          <a:prstGeom prst="rect">
+            <a:avLst/>
+          </a:prstGeom>
+          <a:noFill/>
+        </p:spPr>
+        <p:txBody>
+          <a:bodyPr wrap="none">
+            <a:spAutoFit/>
+          </a:bodyPr>
+          <a:lstStyle/>
+          <a:p>
+            <a:r>
+              <a:rPr sz="3000" b="1">
+                <a:solidFill>
+                  <a:srgbClr val="145A6E"/>
+                </a:solidFill>
+              </a:rPr>
+              <a:t>Robustness: the loss holds in- and out-of-sample</a:t>
+            </a:r>
+          </a:p>
+        </p:txBody>
+      </p:sp>
+      <p:graphicFrame>
+        <p:nvGraphicFramePr>
+          <p:cNvPr id="3" name="Table 2"/>
+          <p:cNvGraphicFramePr>
+            <a:graphicFrameLocks noGrp="1"/>
+          </p:cNvGraphicFramePr>
+          <p:nvPr/>
+        </p:nvGraphicFramePr>
+        <p:xfrm>
+          <a:off x="1005840" y="1737360"/>
+          <a:ext cx="10149840" cy="2377440"/>
+        </p:xfrm>
+        <a:graphic>
+          <a:graphicData uri="http://schemas.openxmlformats.org/drawingml/2006/table">
+            <a:tbl>
+              <a:tblPr firstRow="1" bandRow="1">
+                <a:tableStyleId>{5C22544A-7EE6-4342-B048-85BDC9FD1C3A}</a:tableStyleId>
+              </a:tblPr>
+              <a:tblGrid>
+                <a:gridCol w="2743200"/>
+                <a:gridCol w="1851660"/>
+                <a:gridCol w="1851660"/>
+                <a:gridCol w="1851660"/>
+                <a:gridCol w="1851660"/>
+              </a:tblGrid>
+              <a:tr h="594360">
+                <a:tc>
+                  <a:txBody>
+                    <a:bodyPr/>
+                    <a:lstStyle/>
+                    <a:p>
+                      <a:pPr algn="l"/>
+                      <a:r>
+                        <a:rPr b="1" sz="1600">
+                          <a:solidFill>
+                            <a:srgbClr val="FFFFFF"/>
+                          </a:solidFill>
+                        </a:rPr>
+                        <a:t>Period</a:t>
+                      </a:r>
+                    </a:p>
+                  </a:txBody>
+                  <a:tcPr>
+                    <a:solidFill>
+                      <a:srgbClr val="145A6E"/>
+                    </a:solidFill>
+                  </a:tcPr>
+                </a:tc>
+                <a:tc>
+                  <a:txBody>
+                    <a:bodyPr/>
+                    <a:lstStyle/>
+                    <a:p>
+                      <a:pPr algn="ctr"/>
+                      <a:r>
+                        <a:rPr b="1" sz="1600">
+                          <a:solidFill>
+                            <a:srgbClr val="FFFFFF"/>
+                          </a:solidFill>
+                        </a:rPr>
+                        <a:t>Gross</a:t>
+                      </a:r>
+                    </a:p>
+                  </a:txBody>
+                  <a:tcPr>
+                    <a:solidFill>
+                      <a:srgbClr val="145A6E"/>
+                    </a:solidFill>
+                  </a:tcPr>
+                </a:tc>
+                <a:tc>
+                  <a:txBody>
+                    <a:bodyPr/>
+                    <a:lstStyle/>
+                    <a:p>
+                      <a:pPr algn="ctr"/>
+                      <a:r>
+                        <a:rPr b="1" sz="1600">
+                          <a:solidFill>
+                            <a:srgbClr val="FFFFFF"/>
+                          </a:solidFill>
+                        </a:rPr>
+                        <a:t>Slippage cost</a:t>
+                      </a:r>
+                    </a:p>
+                  </a:txBody>
+                  <a:tcPr>
+                    <a:solidFill>
+                      <a:srgbClr val="145A6E"/>
+                    </a:solidFill>
+                  </a:tcPr>
+                </a:tc>
+                <a:tc>
+                  <a:txBody>
+                    <a:bodyPr/>
+                    <a:lstStyle/>
+                    <a:p>
+                      <a:pPr algn="ctr"/>
+                      <a:r>
+                        <a:rPr b="1" sz="1600">
+                          <a:solidFill>
+                            <a:srgbClr val="FFFFFF"/>
+                          </a:solidFill>
+                        </a:rPr>
+                        <a:t>Net</a:t>
+                      </a:r>
+                    </a:p>
+                  </a:txBody>
+                  <a:tcPr>
+                    <a:solidFill>
+                      <a:srgbClr val="145A6E"/>
+                    </a:solidFill>
+                  </a:tcPr>
+                </a:tc>
+                <a:tc>
+                  <a:txBody>
+                    <a:bodyPr/>
+                    <a:lstStyle/>
+                    <a:p>
+                      <a:pPr algn="ctr"/>
+                      <a:r>
+                        <a:rPr b="1" sz="1600">
+                          <a:solidFill>
+                            <a:srgbClr val="FFFFFF"/>
+                          </a:solidFill>
+                        </a:rPr>
+                        <a:t>Contracts</a:t>
+                      </a:r>
+                    </a:p>
+                  </a:txBody>
+                  <a:tcPr>
+                    <a:solidFill>
+                      <a:srgbClr val="145A6E"/>
+                    </a:solidFill>
+                  </a:tcPr>
+                </a:tc>
+              </a:tr>
+              <a:tr h="594360">
+                <a:tc>
+                  <a:txBody>
+                    <a:bodyPr/>
+                    <a:lstStyle/>
+                    <a:p>
+                      <a:pPr algn="l"/>
+                      <a:r>
+                        <a:rPr sz="1500" b="0">
+                          <a:solidFill>
+                            <a:srgbClr val="222222"/>
+                          </a:solidFill>
+                        </a:rPr>
+                        <a:t>Development</a:t>
+                      </a:r>
+                    </a:p>
+                  </a:txBody>
+                  <a:tcPr>
+                    <a:solidFill>
+                      <a:srgbClr val="FFFFFF"/>
+                    </a:solidFill>
+                  </a:tcPr>
+                </a:tc>
+                <a:tc>
+                  <a:txBody>
+                    <a:bodyPr/>
+                    <a:lstStyle/>
+                    <a:p>
+                      <a:pPr algn="ctr"/>
+                      <a:r>
+                        <a:rPr sz="1500" b="0">
+                          <a:solidFill>
+                            <a:srgbClr val="222222"/>
+                          </a:solidFill>
+                        </a:rPr>
+                        <a:t>+$2,075</a:t>
+                      </a:r>
+                    </a:p>
+                  </a:txBody>
+                  <a:tcPr>
+                    <a:solidFill>
+                      <a:srgbClr val="FFFFFF"/>
+                    </a:solidFill>
+                  </a:tcPr>
+                </a:tc>
+                <a:tc>
+                  <a:txBody>
+                    <a:bodyPr/>
+                    <a:lstStyle/>
+                    <a:p>
+                      <a:pPr algn="ctr"/>
+                      <a:r>
+                        <a:rPr sz="1500" b="0">
+                          <a:solidFill>
+                            <a:srgbClr val="222222"/>
+                          </a:solidFill>
+                        </a:rPr>
+                        <a:t>$46,762.50</a:t>
+                      </a:r>
+                    </a:p>
+                  </a:txBody>
+                  <a:tcPr>
+                    <a:solidFill>
+                      <a:srgbClr val="FFFFFF"/>
+                    </a:solidFill>
+                  </a:tcPr>
+                </a:tc>
+                <a:tc>
+                  <a:txBody>
+                    <a:bodyPr/>
+                    <a:lstStyle/>
+                    <a:p>
+                      <a:pPr algn="ctr"/>
+                      <a:r>
+                        <a:rPr sz="1500" b="0">
+                          <a:solidFill>
+                            <a:srgbClr val="222222"/>
+                          </a:solidFill>
+                        </a:rPr>
+                        <a:t>-$44,687.50</a:t>
+                      </a:r>
+                    </a:p>
+                  </a:txBody>
+                  <a:tcPr>
+                    <a:solidFill>
+                      <a:srgbClr val="FFFFFF"/>
+                    </a:solidFill>
+                  </a:tcPr>
+                </a:tc>
+                <a:tc>
+                  <a:txBody>
+                    <a:bodyPr/>
+                    <a:lstStyle/>
+                    <a:p>
+                      <a:pPr algn="ctr"/>
+                      <a:r>
+                        <a:rPr sz="1500" b="0">
+                          <a:solidFill>
+                            <a:srgbClr val="222222"/>
+                          </a:solidFill>
+                        </a:rPr>
+                        <a:t>3,741</a:t>
+                      </a:r>
+                    </a:p>
+                  </a:txBody>
+                  <a:tcPr>
+                    <a:solidFill>
+                      <a:srgbClr val="FFFFFF"/>
+                    </a:solidFill>
+                  </a:tcPr>
+                </a:tc>
+              </a:tr>
+              <a:tr h="594360">
+                <a:tc>
+                  <a:txBody>
+                    <a:bodyPr/>
+                    <a:lstStyle/>
+                    <a:p>
+                      <a:pPr algn="l"/>
+                      <a:r>
+                        <a:rPr sz="1500" b="0">
+                          <a:solidFill>
+                            <a:srgbClr val="222222"/>
+                          </a:solidFill>
+                        </a:rPr>
+                        <a:t>Held-out</a:t>
+                      </a:r>
+                    </a:p>
+                  </a:txBody>
+                  <a:tcPr>
+                    <a:solidFill>
+                      <a:srgbClr val="FFFFFF"/>
+                    </a:solidFill>
+                  </a:tcPr>
+                </a:tc>
+                <a:tc>
+                  <a:txBody>
+                    <a:bodyPr/>
+                    <a:lstStyle/>
+                    <a:p>
+                      <a:pPr algn="ctr"/>
+                      <a:r>
+                        <a:rPr sz="1500" b="0">
+                          <a:solidFill>
+                            <a:srgbClr val="222222"/>
+                          </a:solidFill>
+                        </a:rPr>
+                        <a:t>+$1,775</a:t>
+                      </a:r>
+                    </a:p>
+                  </a:txBody>
+                  <a:tcPr>
+                    <a:solidFill>
+                      <a:srgbClr val="FFFFFF"/>
+                    </a:solidFill>
+                  </a:tcPr>
+                </a:tc>
+                <a:tc>
+                  <a:txBody>
+                    <a:bodyPr/>
+                    <a:lstStyle/>
+                    <a:p>
+                      <a:pPr algn="ctr"/>
+                      <a:r>
+                        <a:rPr sz="1500" b="0">
+                          <a:solidFill>
+                            <a:srgbClr val="222222"/>
+                          </a:solidFill>
+                        </a:rPr>
+                        <a:t>$19,750.00</a:t>
+                      </a:r>
+                    </a:p>
+                  </a:txBody>
+                  <a:tcPr>
+                    <a:solidFill>
+                      <a:srgbClr val="FFFFFF"/>
+                    </a:solidFill>
+                  </a:tcPr>
+                </a:tc>
+                <a:tc>
+                  <a:txBody>
+                    <a:bodyPr/>
+                    <a:lstStyle/>
+                    <a:p>
+                      <a:pPr algn="ctr"/>
+                      <a:r>
+                        <a:rPr sz="1500" b="0">
+                          <a:solidFill>
+                            <a:srgbClr val="222222"/>
+                          </a:solidFill>
+                        </a:rPr>
+                        <a:t>-$17,975.00</a:t>
+                      </a:r>
+                    </a:p>
+                  </a:txBody>
+                  <a:tcPr>
+                    <a:solidFill>
+                      <a:srgbClr val="FFFFFF"/>
+                    </a:solidFill>
+                  </a:tcPr>
+                </a:tc>
+                <a:tc>
+                  <a:txBody>
+                    <a:bodyPr/>
+                    <a:lstStyle/>
+                    <a:p>
+                      <a:pPr algn="ctr"/>
+                      <a:r>
+                        <a:rPr sz="1500" b="0">
+                          <a:solidFill>
+                            <a:srgbClr val="222222"/>
+                          </a:solidFill>
+                        </a:rPr>
+                        <a:t>1,580</a:t>
+                      </a:r>
+                    </a:p>
+                  </a:txBody>
+                  <a:tcPr>
+                    <a:solidFill>
+                      <a:srgbClr val="FFFFFF"/>
+                    </a:solidFill>
+                  </a:tcPr>
+                </a:tc>
+              </a:tr>
+              <a:tr h="594360">
+                <a:tc>
+                  <a:txBody>
+                    <a:bodyPr/>
+                    <a:lstStyle/>
+                    <a:p>
+                      <a:pPr algn="l"/>
+                      <a:r>
+                        <a:rPr sz="1500" b="1">
+                          <a:solidFill>
+                            <a:srgbClr val="222222"/>
+                          </a:solidFill>
+                        </a:rPr>
+                        <a:t>Full period</a:t>
+                      </a:r>
+                    </a:p>
+                  </a:txBody>
+                  <a:tcPr>
+                    <a:solidFill>
+                      <a:srgbClr val="EAF3F6"/>
+                    </a:solidFill>
+                  </a:tcPr>
+                </a:tc>
+                <a:tc>
+                  <a:txBody>
+                    <a:bodyPr/>
+                    <a:lstStyle/>
+                    <a:p>
+                      <a:pPr algn="ctr"/>
+                      <a:r>
+                        <a:rPr sz="1500" b="1">
+                          <a:solidFill>
+                            <a:srgbClr val="222222"/>
+                          </a:solidFill>
+                        </a:rPr>
+                        <a:t>+$3,850</a:t>
+                      </a:r>
+                    </a:p>
+                  </a:txBody>
+                  <a:tcPr>
+                    <a:solidFill>
+                      <a:srgbClr val="EAF3F6"/>
+                    </a:solidFill>
+                  </a:tcPr>
+                </a:tc>
+                <a:tc>
+                  <a:txBody>
+                    <a:bodyPr/>
+                    <a:lstStyle/>
+                    <a:p>
+                      <a:pPr algn="ctr"/>
+                      <a:r>
+                        <a:rPr sz="1500" b="1">
+                          <a:solidFill>
+                            <a:srgbClr val="222222"/>
+                          </a:solidFill>
+                        </a:rPr>
+                        <a:t>$66,512.50</a:t>
+                      </a:r>
+                    </a:p>
+                  </a:txBody>
+                  <a:tcPr>
+                    <a:solidFill>
+                      <a:srgbClr val="EAF3F6"/>
+                    </a:solidFill>
+                  </a:tcPr>
+                </a:tc>
+                <a:tc>
+                  <a:txBody>
+                    <a:bodyPr/>
+                    <a:lstStyle/>
+                    <a:p>
+                      <a:pPr algn="ctr"/>
+                      <a:r>
+                        <a:rPr sz="1500" b="1">
+                          <a:solidFill>
+                            <a:srgbClr val="222222"/>
+                          </a:solidFill>
+                        </a:rPr>
+                        <a:t>-$62,662.50</a:t>
+                      </a:r>
+                    </a:p>
+                  </a:txBody>
+                  <a:tcPr>
+                    <a:solidFill>
+                      <a:srgbClr val="EAF3F6"/>
+                    </a:solidFill>
+                  </a:tcPr>
+                </a:tc>
+                <a:tc>
+                  <a:txBody>
+                    <a:bodyPr/>
+                    <a:lstStyle/>
+                    <a:p>
+                      <a:pPr algn="ctr"/>
+                      <a:r>
+                        <a:rPr sz="1500" b="1">
+                          <a:solidFill>
+                            <a:srgbClr val="222222"/>
+                          </a:solidFill>
+                        </a:rPr>
+                        <a:t>5,321</a:t>
+                      </a:r>
+                    </a:p>
+                  </a:txBody>
+                  <a:tcPr>
+                    <a:solidFill>
+                      <a:srgbClr val="EAF3F6"/>
+                    </a:solidFill>
+                  </a:tcPr>
+                </a:tc>
+              </a:tr>
+            </a:tbl>
+          </a:graphicData>
+        </a:graphic>
+      </p:graphicFrame>
+      <p:sp>
+        <p:nvSpPr>
+          <p:cNvPr id="4" name="TextBox 3"/>
+          <p:cNvSpPr txBox="1"/>
+          <p:nvPr/>
+        </p:nvSpPr>
+        <p:spPr>
+          <a:xfrm>
+            <a:off x="1005840" y="4480560"/>
+            <a:ext cx="10149840" cy="1463040"/>
+          </a:xfrm>
+          <a:prstGeom prst="rect">
+            <a:avLst/>
+          </a:prstGeom>
+          <a:noFill/>
+        </p:spPr>
+        <p:txBody>
+          <a:bodyPr wrap="square">
+            <a:spAutoFit/>
+          </a:bodyPr>
+          <a:lstStyle/>
+          <a:p>
+            <a:pPr>
+              <a:spcAft>
+                <a:spcPts val="600"/>
+              </a:spcAft>
+            </a:pPr>
+            <a:r>
+              <a:rPr sz="1600">
+                <a:solidFill>
+                  <a:srgbClr val="222222"/>
+                </a:solidFill>
+              </a:rPr>
+              <a:t>•  Gross P&amp;L is roughly flat in BOTH the development and the held-out period - no edge in either.</a:t>
+            </a:r>
+          </a:p>
+          <a:p>
+            <a:pPr>
+              <a:spcAft>
+                <a:spcPts val="600"/>
+              </a:spcAft>
+            </a:pPr>
+            <a:r>
+              <a:rPr sz="1600">
+                <a:solidFill>
+                  <a:srgbClr val="222222"/>
+                </a:solidFill>
+              </a:rPr>
+              <a:t>•  Slippage alone drives the loss; the result is not an artifact of one sample.</a:t>
+            </a:r>
+          </a:p>
+          <a:p>
+            <a:pPr>
+              <a:spcAft>
+                <a:spcPts val="600"/>
+              </a:spcAft>
+            </a:pPr>
+            <a:r>
+              <a:rPr sz="1600">
+                <a:solidFill>
+                  <a:srgbClr val="222222"/>
+                </a:solidFill>
+              </a:rPr>
+              <a:t>•  Development + held-out = full on every column, so the split is a clean chronological partition.</a:t>
             </a:r>
           </a:p>
         </p:txBody>

</xml_diff>

<commit_message>
Add robustness (period-split) table slide to presentation deck (#27)
Insert a slide after the headline result showing gross/slippage/net P&L and
contracts for the development, held-out, and full periods: the rule loses in
both in-sample and out-of-sample, with gross roughly flat throughout.

Co-authored-by: Claude Opus 4.8 (1M context) <noreply@anthropic.com>
</commit_message>
<xml_diff>
--- a/presentation/FINM37000_Corn_Futures.pptx
+++ b/presentation/FINM37000_Corn_Futures.pptx
@@ -13,6 +13,7 @@
     <p:sldId id="258" r:id="rId4"/>
     <p:sldId id="259" r:id="rId5"/>
     <p:sldId id="260" r:id="rId6"/>
+    <p:sldId id="263" r:id="rId14"/>
     <p:sldId id="261" r:id="rId7"/>
     <p:sldId id="262" r:id="rId8"/>
   </p:sldIdLst>
@@ -739,6 +740,31 @@
         </p:nvSpPr>
         <p:spPr/>
       </p:sp>
+    </p:spTree>
+  </p:cSld>
+  <p:clrMapOvr>
+    <a:masterClrMapping/>
+  </p:clrMapOvr>
+</p:notes>
+</file>
+
+<file path=ppt/notesSlides/notesSlide8.xml><?xml version="1.0" encoding="utf-8"?>
+<p:notes xmlns:a="http://schemas.openxmlformats.org/drawingml/2006/main" xmlns:p="http://schemas.openxmlformats.org/presentationml/2006/main" xmlns:r="http://schemas.openxmlformats.org/officeDocument/2006/relationships">
+  <p:cSld>
+    <p:spTree>
+      <p:nvGrpSpPr>
+        <p:cNvPr id="1" name=""/>
+        <p:cNvGrpSpPr/>
+        <p:nvPr/>
+      </p:nvGrpSpPr>
+      <p:grpSpPr>
+        <a:xfrm>
+          <a:off x="0" y="0"/>
+          <a:ext cx="0" cy="0"/>
+          <a:chOff x="0" y="0"/>
+          <a:chExt cx="0" cy="0"/>
+        </a:xfrm>
+      </p:grpSpPr>
     </p:spTree>
   </p:cSld>
   <p:clrMapOvr>
@@ -4782,6 +4808,602 @@
                 </a:solidFill>
               </a:rPr>
               <a:t>–  order-flow features; source an expectations series to finish the USDA study</a:t>
+            </a:r>
+          </a:p>
+        </p:txBody>
+      </p:sp>
+    </p:spTree>
+  </p:cSld>
+  <p:clrMapOvr>
+    <a:masterClrMapping/>
+  </p:clrMapOvr>
+</p:sld>
+</file>
+
+<file path=ppt/slides/slide8.xml><?xml version="1.0" encoding="utf-8"?>
+<p:sld xmlns:a="http://schemas.openxmlformats.org/drawingml/2006/main" xmlns:p="http://schemas.openxmlformats.org/presentationml/2006/main" xmlns:r="http://schemas.openxmlformats.org/officeDocument/2006/relationships">
+  <p:cSld>
+    <p:spTree>
+      <p:nvGrpSpPr>
+        <p:cNvPr id="1" name=""/>
+        <p:cNvGrpSpPr/>
+        <p:nvPr/>
+      </p:nvGrpSpPr>
+      <p:grpSpPr/>
+      <p:sp>
+        <p:nvSpPr>
+          <p:cNvPr id="2" name="TextBox 1"/>
+          <p:cNvSpPr txBox="1"/>
+          <p:nvPr/>
+        </p:nvSpPr>
+        <p:spPr>
+          <a:xfrm>
+            <a:off x="548640" y="320040"/>
+            <a:ext cx="11064240" cy="822960"/>
+          </a:xfrm>
+          <a:prstGeom prst="rect">
+            <a:avLst/>
+          </a:prstGeom>
+          <a:noFill/>
+        </p:spPr>
+        <p:txBody>
+          <a:bodyPr wrap="none">
+            <a:spAutoFit/>
+          </a:bodyPr>
+          <a:lstStyle/>
+          <a:p>
+            <a:r>
+              <a:rPr sz="3000" b="1">
+                <a:solidFill>
+                  <a:srgbClr val="145A6E"/>
+                </a:solidFill>
+              </a:rPr>
+              <a:t>Robustness: the loss holds in- and out-of-sample</a:t>
+            </a:r>
+          </a:p>
+        </p:txBody>
+      </p:sp>
+      <p:graphicFrame>
+        <p:nvGraphicFramePr>
+          <p:cNvPr id="3" name="Table 2"/>
+          <p:cNvGraphicFramePr>
+            <a:graphicFrameLocks noGrp="1"/>
+          </p:cNvGraphicFramePr>
+          <p:nvPr/>
+        </p:nvGraphicFramePr>
+        <p:xfrm>
+          <a:off x="1005840" y="1737360"/>
+          <a:ext cx="10149840" cy="2377440"/>
+        </p:xfrm>
+        <a:graphic>
+          <a:graphicData uri="http://schemas.openxmlformats.org/drawingml/2006/table">
+            <a:tbl>
+              <a:tblPr firstRow="1" bandRow="1">
+                <a:tableStyleId>{5C22544A-7EE6-4342-B048-85BDC9FD1C3A}</a:tableStyleId>
+              </a:tblPr>
+              <a:tblGrid>
+                <a:gridCol w="2743200"/>
+                <a:gridCol w="1851660"/>
+                <a:gridCol w="1851660"/>
+                <a:gridCol w="1851660"/>
+                <a:gridCol w="1851660"/>
+              </a:tblGrid>
+              <a:tr h="594360">
+                <a:tc>
+                  <a:txBody>
+                    <a:bodyPr/>
+                    <a:lstStyle/>
+                    <a:p>
+                      <a:pPr algn="l"/>
+                      <a:r>
+                        <a:rPr b="1" sz="1600">
+                          <a:solidFill>
+                            <a:srgbClr val="FFFFFF"/>
+                          </a:solidFill>
+                        </a:rPr>
+                        <a:t>Period</a:t>
+                      </a:r>
+                    </a:p>
+                  </a:txBody>
+                  <a:tcPr>
+                    <a:solidFill>
+                      <a:srgbClr val="145A6E"/>
+                    </a:solidFill>
+                  </a:tcPr>
+                </a:tc>
+                <a:tc>
+                  <a:txBody>
+                    <a:bodyPr/>
+                    <a:lstStyle/>
+                    <a:p>
+                      <a:pPr algn="ctr"/>
+                      <a:r>
+                        <a:rPr b="1" sz="1600">
+                          <a:solidFill>
+                            <a:srgbClr val="FFFFFF"/>
+                          </a:solidFill>
+                        </a:rPr>
+                        <a:t>Gross</a:t>
+                      </a:r>
+                    </a:p>
+                  </a:txBody>
+                  <a:tcPr>
+                    <a:solidFill>
+                      <a:srgbClr val="145A6E"/>
+                    </a:solidFill>
+                  </a:tcPr>
+                </a:tc>
+                <a:tc>
+                  <a:txBody>
+                    <a:bodyPr/>
+                    <a:lstStyle/>
+                    <a:p>
+                      <a:pPr algn="ctr"/>
+                      <a:r>
+                        <a:rPr b="1" sz="1600">
+                          <a:solidFill>
+                            <a:srgbClr val="FFFFFF"/>
+                          </a:solidFill>
+                        </a:rPr>
+                        <a:t>Slippage cost</a:t>
+                      </a:r>
+                    </a:p>
+                  </a:txBody>
+                  <a:tcPr>
+                    <a:solidFill>
+                      <a:srgbClr val="145A6E"/>
+                    </a:solidFill>
+                  </a:tcPr>
+                </a:tc>
+                <a:tc>
+                  <a:txBody>
+                    <a:bodyPr/>
+                    <a:lstStyle/>
+                    <a:p>
+                      <a:pPr algn="ctr"/>
+                      <a:r>
+                        <a:rPr b="1" sz="1600">
+                          <a:solidFill>
+                            <a:srgbClr val="FFFFFF"/>
+                          </a:solidFill>
+                        </a:rPr>
+                        <a:t>Net</a:t>
+                      </a:r>
+                    </a:p>
+                  </a:txBody>
+                  <a:tcPr>
+                    <a:solidFill>
+                      <a:srgbClr val="145A6E"/>
+                    </a:solidFill>
+                  </a:tcPr>
+                </a:tc>
+                <a:tc>
+                  <a:txBody>
+                    <a:bodyPr/>
+                    <a:lstStyle/>
+                    <a:p>
+                      <a:pPr algn="ctr"/>
+                      <a:r>
+                        <a:rPr b="1" sz="1600">
+                          <a:solidFill>
+                            <a:srgbClr val="FFFFFF"/>
+                          </a:solidFill>
+                        </a:rPr>
+                        <a:t>Contracts</a:t>
+                      </a:r>
+                    </a:p>
+                  </a:txBody>
+                  <a:tcPr>
+                    <a:solidFill>
+                      <a:srgbClr val="145A6E"/>
+                    </a:solidFill>
+                  </a:tcPr>
+                </a:tc>
+              </a:tr>
+              <a:tr h="594360">
+                <a:tc>
+                  <a:txBody>
+                    <a:bodyPr/>
+                    <a:lstStyle/>
+                    <a:p>
+                      <a:pPr algn="l"/>
+                      <a:r>
+                        <a:rPr sz="1500" b="0">
+                          <a:solidFill>
+                            <a:srgbClr val="222222"/>
+                          </a:solidFill>
+                        </a:rPr>
+                        <a:t>Development</a:t>
+                      </a:r>
+                    </a:p>
+                  </a:txBody>
+                  <a:tcPr>
+                    <a:solidFill>
+                      <a:srgbClr val="FFFFFF"/>
+                    </a:solidFill>
+                  </a:tcPr>
+                </a:tc>
+                <a:tc>
+                  <a:txBody>
+                    <a:bodyPr/>
+                    <a:lstStyle/>
+                    <a:p>
+                      <a:pPr algn="ctr"/>
+                      <a:r>
+                        <a:rPr sz="1500" b="0">
+                          <a:solidFill>
+                            <a:srgbClr val="222222"/>
+                          </a:solidFill>
+                        </a:rPr>
+                        <a:t>+$2,075</a:t>
+                      </a:r>
+                    </a:p>
+                  </a:txBody>
+                  <a:tcPr>
+                    <a:solidFill>
+                      <a:srgbClr val="FFFFFF"/>
+                    </a:solidFill>
+                  </a:tcPr>
+                </a:tc>
+                <a:tc>
+                  <a:txBody>
+                    <a:bodyPr/>
+                    <a:lstStyle/>
+                    <a:p>
+                      <a:pPr algn="ctr"/>
+                      <a:r>
+                        <a:rPr sz="1500" b="0">
+                          <a:solidFill>
+                            <a:srgbClr val="222222"/>
+                          </a:solidFill>
+                        </a:rPr>
+                        <a:t>$46,762.50</a:t>
+                      </a:r>
+                    </a:p>
+                  </a:txBody>
+                  <a:tcPr>
+                    <a:solidFill>
+                      <a:srgbClr val="FFFFFF"/>
+                    </a:solidFill>
+                  </a:tcPr>
+                </a:tc>
+                <a:tc>
+                  <a:txBody>
+                    <a:bodyPr/>
+                    <a:lstStyle/>
+                    <a:p>
+                      <a:pPr algn="ctr"/>
+                      <a:r>
+                        <a:rPr sz="1500" b="0">
+                          <a:solidFill>
+                            <a:srgbClr val="222222"/>
+                          </a:solidFill>
+                        </a:rPr>
+                        <a:t>-$44,687.50</a:t>
+                      </a:r>
+                    </a:p>
+                  </a:txBody>
+                  <a:tcPr>
+                    <a:solidFill>
+                      <a:srgbClr val="FFFFFF"/>
+                    </a:solidFill>
+                  </a:tcPr>
+                </a:tc>
+                <a:tc>
+                  <a:txBody>
+                    <a:bodyPr/>
+                    <a:lstStyle/>
+                    <a:p>
+                      <a:pPr algn="ctr"/>
+                      <a:r>
+                        <a:rPr sz="1500" b="0">
+                          <a:solidFill>
+                            <a:srgbClr val="222222"/>
+                          </a:solidFill>
+                        </a:rPr>
+                        <a:t>3,741</a:t>
+                      </a:r>
+                    </a:p>
+                  </a:txBody>
+                  <a:tcPr>
+                    <a:solidFill>
+                      <a:srgbClr val="FFFFFF"/>
+                    </a:solidFill>
+                  </a:tcPr>
+                </a:tc>
+              </a:tr>
+              <a:tr h="594360">
+                <a:tc>
+                  <a:txBody>
+                    <a:bodyPr/>
+                    <a:lstStyle/>
+                    <a:p>
+                      <a:pPr algn="l"/>
+                      <a:r>
+                        <a:rPr sz="1500" b="0">
+                          <a:solidFill>
+                            <a:srgbClr val="222222"/>
+                          </a:solidFill>
+                        </a:rPr>
+                        <a:t>Held-out</a:t>
+                      </a:r>
+                    </a:p>
+                  </a:txBody>
+                  <a:tcPr>
+                    <a:solidFill>
+                      <a:srgbClr val="FFFFFF"/>
+                    </a:solidFill>
+                  </a:tcPr>
+                </a:tc>
+                <a:tc>
+                  <a:txBody>
+                    <a:bodyPr/>
+                    <a:lstStyle/>
+                    <a:p>
+                      <a:pPr algn="ctr"/>
+                      <a:r>
+                        <a:rPr sz="1500" b="0">
+                          <a:solidFill>
+                            <a:srgbClr val="222222"/>
+                          </a:solidFill>
+                        </a:rPr>
+                        <a:t>+$1,775</a:t>
+                      </a:r>
+                    </a:p>
+                  </a:txBody>
+                  <a:tcPr>
+                    <a:solidFill>
+                      <a:srgbClr val="FFFFFF"/>
+                    </a:solidFill>
+                  </a:tcPr>
+                </a:tc>
+                <a:tc>
+                  <a:txBody>
+                    <a:bodyPr/>
+                    <a:lstStyle/>
+                    <a:p>
+                      <a:pPr algn="ctr"/>
+                      <a:r>
+                        <a:rPr sz="1500" b="0">
+                          <a:solidFill>
+                            <a:srgbClr val="222222"/>
+                          </a:solidFill>
+                        </a:rPr>
+                        <a:t>$19,750.00</a:t>
+                      </a:r>
+                    </a:p>
+                  </a:txBody>
+                  <a:tcPr>
+                    <a:solidFill>
+                      <a:srgbClr val="FFFFFF"/>
+                    </a:solidFill>
+                  </a:tcPr>
+                </a:tc>
+                <a:tc>
+                  <a:txBody>
+                    <a:bodyPr/>
+                    <a:lstStyle/>
+                    <a:p>
+                      <a:pPr algn="ctr"/>
+                      <a:r>
+                        <a:rPr sz="1500" b="0">
+                          <a:solidFill>
+                            <a:srgbClr val="222222"/>
+                          </a:solidFill>
+                        </a:rPr>
+                        <a:t>-$17,975.00</a:t>
+                      </a:r>
+                    </a:p>
+                  </a:txBody>
+                  <a:tcPr>
+                    <a:solidFill>
+                      <a:srgbClr val="FFFFFF"/>
+                    </a:solidFill>
+                  </a:tcPr>
+                </a:tc>
+                <a:tc>
+                  <a:txBody>
+                    <a:bodyPr/>
+                    <a:lstStyle/>
+                    <a:p>
+                      <a:pPr algn="ctr"/>
+                      <a:r>
+                        <a:rPr sz="1500" b="0">
+                          <a:solidFill>
+                            <a:srgbClr val="222222"/>
+                          </a:solidFill>
+                        </a:rPr>
+                        <a:t>1,580</a:t>
+                      </a:r>
+                    </a:p>
+                  </a:txBody>
+                  <a:tcPr>
+                    <a:solidFill>
+                      <a:srgbClr val="FFFFFF"/>
+                    </a:solidFill>
+                  </a:tcPr>
+                </a:tc>
+              </a:tr>
+              <a:tr h="594360">
+                <a:tc>
+                  <a:txBody>
+                    <a:bodyPr/>
+                    <a:lstStyle/>
+                    <a:p>
+                      <a:pPr algn="l"/>
+                      <a:r>
+                        <a:rPr sz="1500" b="1">
+                          <a:solidFill>
+                            <a:srgbClr val="222222"/>
+                          </a:solidFill>
+                        </a:rPr>
+                        <a:t>Full period</a:t>
+                      </a:r>
+                    </a:p>
+                  </a:txBody>
+                  <a:tcPr>
+                    <a:solidFill>
+                      <a:srgbClr val="EAF3F6"/>
+                    </a:solidFill>
+                  </a:tcPr>
+                </a:tc>
+                <a:tc>
+                  <a:txBody>
+                    <a:bodyPr/>
+                    <a:lstStyle/>
+                    <a:p>
+                      <a:pPr algn="ctr"/>
+                      <a:r>
+                        <a:rPr sz="1500" b="1">
+                          <a:solidFill>
+                            <a:srgbClr val="222222"/>
+                          </a:solidFill>
+                        </a:rPr>
+                        <a:t>+$3,850</a:t>
+                      </a:r>
+                    </a:p>
+                  </a:txBody>
+                  <a:tcPr>
+                    <a:solidFill>
+                      <a:srgbClr val="EAF3F6"/>
+                    </a:solidFill>
+                  </a:tcPr>
+                </a:tc>
+                <a:tc>
+                  <a:txBody>
+                    <a:bodyPr/>
+                    <a:lstStyle/>
+                    <a:p>
+                      <a:pPr algn="ctr"/>
+                      <a:r>
+                        <a:rPr sz="1500" b="1">
+                          <a:solidFill>
+                            <a:srgbClr val="222222"/>
+                          </a:solidFill>
+                        </a:rPr>
+                        <a:t>$66,512.50</a:t>
+                      </a:r>
+                    </a:p>
+                  </a:txBody>
+                  <a:tcPr>
+                    <a:solidFill>
+                      <a:srgbClr val="EAF3F6"/>
+                    </a:solidFill>
+                  </a:tcPr>
+                </a:tc>
+                <a:tc>
+                  <a:txBody>
+                    <a:bodyPr/>
+                    <a:lstStyle/>
+                    <a:p>
+                      <a:pPr algn="ctr"/>
+                      <a:r>
+                        <a:rPr sz="1500" b="1">
+                          <a:solidFill>
+                            <a:srgbClr val="222222"/>
+                          </a:solidFill>
+                        </a:rPr>
+                        <a:t>-$62,662.50</a:t>
+                      </a:r>
+                    </a:p>
+                  </a:txBody>
+                  <a:tcPr>
+                    <a:solidFill>
+                      <a:srgbClr val="EAF3F6"/>
+                    </a:solidFill>
+                  </a:tcPr>
+                </a:tc>
+                <a:tc>
+                  <a:txBody>
+                    <a:bodyPr/>
+                    <a:lstStyle/>
+                    <a:p>
+                      <a:pPr algn="ctr"/>
+                      <a:r>
+                        <a:rPr sz="1500" b="1">
+                          <a:solidFill>
+                            <a:srgbClr val="222222"/>
+                          </a:solidFill>
+                        </a:rPr>
+                        <a:t>5,321</a:t>
+                      </a:r>
+                    </a:p>
+                  </a:txBody>
+                  <a:tcPr>
+                    <a:solidFill>
+                      <a:srgbClr val="EAF3F6"/>
+                    </a:solidFill>
+                  </a:tcPr>
+                </a:tc>
+              </a:tr>
+            </a:tbl>
+          </a:graphicData>
+        </a:graphic>
+      </p:graphicFrame>
+      <p:sp>
+        <p:nvSpPr>
+          <p:cNvPr id="4" name="TextBox 3"/>
+          <p:cNvSpPr txBox="1"/>
+          <p:nvPr/>
+        </p:nvSpPr>
+        <p:spPr>
+          <a:xfrm>
+            <a:off x="1005840" y="4480560"/>
+            <a:ext cx="10149840" cy="1463040"/>
+          </a:xfrm>
+          <a:prstGeom prst="rect">
+            <a:avLst/>
+          </a:prstGeom>
+          <a:noFill/>
+        </p:spPr>
+        <p:txBody>
+          <a:bodyPr wrap="square">
+            <a:spAutoFit/>
+          </a:bodyPr>
+          <a:lstStyle/>
+          <a:p>
+            <a:pPr>
+              <a:spcAft>
+                <a:spcPts val="600"/>
+              </a:spcAft>
+            </a:pPr>
+            <a:r>
+              <a:rPr sz="1600">
+                <a:solidFill>
+                  <a:srgbClr val="222222"/>
+                </a:solidFill>
+              </a:rPr>
+              <a:t>•  Gross P&amp;L is roughly flat in BOTH the development and the held-out period - no edge in either.</a:t>
+            </a:r>
+          </a:p>
+          <a:p>
+            <a:pPr>
+              <a:spcAft>
+                <a:spcPts val="600"/>
+              </a:spcAft>
+            </a:pPr>
+            <a:r>
+              <a:rPr sz="1600">
+                <a:solidFill>
+                  <a:srgbClr val="222222"/>
+                </a:solidFill>
+              </a:rPr>
+              <a:t>•  Slippage alone drives the loss; the result is not an artifact of one sample.</a:t>
+            </a:r>
+          </a:p>
+          <a:p>
+            <a:pPr>
+              <a:spcAft>
+                <a:spcPts val="600"/>
+              </a:spcAft>
+            </a:pPr>
+            <a:r>
+              <a:rPr sz="1600">
+                <a:solidFill>
+                  <a:srgbClr val="222222"/>
+                </a:solidFill>
+              </a:rPr>
+              <a:t>•  Development + held-out = full on every column, so the split is a clean chronological partition.</a:t>
             </a:r>
           </a:p>
         </p:txBody>

</xml_diff>